<commit_message>
Update PowerPoint templates with IBM Watson Assistant Integration ID bad150a7-6816-40db-9249-10be96c432f4 and project details
</commit_message>
<xml_diff>
--- a/AICTE_IBM_BOB_Project_Submission_Template.pptx
+++ b/AICTE_IBM_BOB_Project_Submission_Template.pptx
@@ -14914,6 +14914,22 @@
               <a:t>Repository includes complete source code: app.py, auth.py, tikz_generator.py, granite_client.py, validator.py, renderer.py, prompt_templates.py, requirements.txt, and submission documentation.</a:t>
             </a:r>
           </a:p>
+          <a:p/>
+          <a:p>
+            <a:r>
+              <a:t>• IBM Watson Assistant Integration:</a:t>
+            </a:r>
+          </a:p>
+          <a:p>
+            <a:r>
+              <a:t>Integration ID: bad150a7-6816-40db-9249-10be96c432f4</a:t>
+            </a:r>
+          </a:p>
+          <a:p>
+            <a:r>
+              <a:t>Region: au-syd</a:t>
+            </a:r>
+          </a:p>
         </p:txBody>
       </p:sp>
       <p:sp>
@@ -17118,7 +17134,7 @@
           </a:p>
           <a:p>
             <a:r>
-              <a:t>1. AI Chatbot Studio Agent – Engages in natural dialogue using Streamlit st.chat_message to understand user intent, generate TikZ diagrams, and apply context-aware edits.</a:t>
+              <a:t>1. IBM Watson Assistant &amp; AI Chatbot Agent – Engages in natural dialogue via IBM Watson Assistant WebChat (Integration: bad150a7-6816-40db-9249-10be96c432f4) and Streamlit AI Chat Studio to understand user intent, generate TikZ diagrams, and apply context-aware edits.</a:t>
             </a:r>
           </a:p>
           <a:p>
@@ -17298,7 +17314,8 @@
           <a:p/>
           <a:p>
             <a:r>
-              <a:t>IBM watsonx.ai REST API – Handles model inference, token management, and scalable cloud execution.</a:t>
+              <a:t>IBM watsonx.ai REST API – Handles model inference, token management, and scalable cloud execution.
+- IBM Watson Assistant WebChat &amp; NLU Integration (Integration ID: bad150a7-6816-40db-9249-10be96c432f4, Region: au-syd).</a:t>
             </a:r>
           </a:p>
           <a:p/>

</xml_diff>

<commit_message>
Update project architecture sequence diagram with IBM Watson & TikZ Studio workflow
</commit_message>
<xml_diff>
--- a/AICTE_IBM_BOB_Project_Submission_Template.pptx
+++ b/AICTE_IBM_BOB_Project_Submission_Template.pptx
@@ -14930,6 +14930,22 @@
               <a:t>Region: au-syd</a:t>
             </a:r>
           </a:p>
+          <a:p/>
+          <a:p>
+            <a:r>
+              <a:t>• IBM Watson Assistant Integration:</a:t>
+            </a:r>
+          </a:p>
+          <a:p>
+            <a:r>
+              <a:t>Integration ID: bad150a7-6816-40db-9249-10be96c432f4</a:t>
+            </a:r>
+          </a:p>
+          <a:p>
+            <a:r>
+              <a:t>Region: au-syd</a:t>
+            </a:r>
+          </a:p>
         </p:txBody>
       </p:sp>
       <p:sp>
@@ -18108,28 +18124,22 @@
       </p:sp>
       <p:pic>
         <p:nvPicPr>
-          <p:cNvPr id="5" name="Picture 4">
-            <a:extLst>
-              <a:ext uri="{FF2B5EF4-FFF2-40B4-BE49-F238E27FC236}">
-                <a16:creationId xmlns:a16="http://schemas.microsoft.com/office/drawing/2014/main" id="{6697535D-EBF5-41DE-E93B-760133BF95C6}"/>
-              </a:ext>
-            </a:extLst>
-          </p:cNvPr>
+          <p:cNvPr id="3" name="Picture 2" descr="architecture_diagram.jpg"/>
           <p:cNvPicPr>
             <a:picLocks noChangeAspect="1"/>
           </p:cNvPicPr>
           <p:nvPr/>
         </p:nvPicPr>
         <p:blipFill>
-          <a:blip r:embed="rId3"/>
+          <a:blip r:embed="rId4"/>
           <a:stretch>
             <a:fillRect/>
           </a:stretch>
         </p:blipFill>
         <p:spPr>
           <a:xfrm>
-            <a:off x="537590" y="1053082"/>
-            <a:ext cx="10550792" cy="4276002"/>
+            <a:off x="914400" y="1828800"/>
+            <a:ext cx="7315200" cy="4082902"/>
           </a:xfrm>
           <a:prstGeom prst="rect">
             <a:avLst/>

</xml_diff>